<commit_message>
[MATH-12] docs: develop the Navier-Stokes video production package
Build the storyboard, narration, captions and production workflow; consolidate English localization, platform-cost guidance, AI-research context, prompts and initial production assets.

Original-snapshot: 46ac16ae32a508c5a07191254e57d0302976ab6a

Tasks: fssrepository/myscoutee-roadmap#54
</commit_message>
<xml_diff>
--- a/guides/pitches/output/Millennium_Math_Problems_Project_Overview_v1.0.0_EN.pptx
+++ b/guides/pitches/output/Millennium_Math_Problems_Project_Overview_v1.0.0_EN.pptx
@@ -67,7 +67,7 @@
         <p:txBody>
           <a:bodyPr/>
           <a:p>
-            <a:fld id="{1B03175E-167B-408D-BDA4-98B73F15E66C}" type="slidenum">
+            <a:fld id="{4A8C8F92-41CB-40CC-B1E0-1CBF824AB382}" type="slidenum">
               <a:t>&lt;#&gt;</a:t>
             </a:fld>
           </a:p>
@@ -255,7 +255,7 @@
         <p:txBody>
           <a:bodyPr/>
           <a:p>
-            <a:fld id="{44BE6982-E6B9-49D9-A4D5-02E11612C216}" type="slidenum">
+            <a:fld id="{D03CB748-723D-4C8E-88ED-F7DEF9563E52}" type="slidenum">
               <a:t>&lt;#&gt;</a:t>
             </a:fld>
           </a:p>
@@ -511,7 +511,7 @@
         <p:txBody>
           <a:bodyPr/>
           <a:p>
-            <a:fld id="{48A1EDEF-AD1C-4015-9E35-F9B00BBBAE61}" type="slidenum">
+            <a:fld id="{D01DBC8E-1F06-44A9-954A-1CD95A2E361F}" type="slidenum">
               <a:t>&lt;#&gt;</a:t>
             </a:fld>
           </a:p>
@@ -835,7 +835,7 @@
         <p:txBody>
           <a:bodyPr/>
           <a:p>
-            <a:fld id="{24A98141-A6D9-4705-ADA4-FAB076D9FABD}" type="slidenum">
+            <a:fld id="{01CBF15C-94BB-4567-BF80-9D946856C8FB}" type="slidenum">
               <a:t>&lt;#&gt;</a:t>
             </a:fld>
           </a:p>
@@ -992,7 +992,7 @@
         <p:txBody>
           <a:bodyPr/>
           <a:p>
-            <a:fld id="{0DFDD374-011A-4265-B12F-EB504B97D48F}" type="slidenum">
+            <a:fld id="{AAD5C4EB-C50E-4685-AC71-2B497B8578F2}" type="slidenum">
               <a:t>&lt;#&gt;</a:t>
             </a:fld>
           </a:p>
@@ -1146,7 +1146,7 @@
         <p:txBody>
           <a:bodyPr/>
           <a:p>
-            <a:fld id="{4956B267-1BDB-4552-A4CE-2DF498F557DC}" type="slidenum">
+            <a:fld id="{18D88305-71FA-4D46-BE70-95E0C1E7C454}" type="slidenum">
               <a:t>&lt;#&gt;</a:t>
             </a:fld>
           </a:p>
@@ -1334,7 +1334,7 @@
         <p:txBody>
           <a:bodyPr/>
           <a:p>
-            <a:fld id="{73916920-20DA-4AE9-BB9B-8FF344603739}" type="slidenum">
+            <a:fld id="{095D1C5C-C2BA-40C8-97BC-DFBB08065342}" type="slidenum">
               <a:t>&lt;#&gt;</a:t>
             </a:fld>
           </a:p>
@@ -1454,7 +1454,7 @@
         <p:txBody>
           <a:bodyPr/>
           <a:p>
-            <a:fld id="{255D7B31-5984-44FE-9697-ABDEB741FC08}" type="slidenum">
+            <a:fld id="{E0D418C7-D2EB-4D97-ACA6-B28476C44FAA}" type="slidenum">
               <a:t>&lt;#&gt;</a:t>
             </a:fld>
           </a:p>
@@ -1574,7 +1574,7 @@
         <p:txBody>
           <a:bodyPr/>
           <a:p>
-            <a:fld id="{8A4E951D-066A-448C-BE9B-545D6770872C}" type="slidenum">
+            <a:fld id="{9B64613A-9462-49BF-A53F-D2556F9B8564}" type="slidenum">
               <a:t>&lt;#&gt;</a:t>
             </a:fld>
           </a:p>
@@ -1796,7 +1796,7 @@
         <p:txBody>
           <a:bodyPr/>
           <a:p>
-            <a:fld id="{7802A158-370F-43B0-B2BE-48630D40E7E7}" type="slidenum">
+            <a:fld id="{ABAF194B-EA8A-4AE5-A20D-1D4FF4EE40ED}" type="slidenum">
               <a:t>&lt;#&gt;</a:t>
             </a:fld>
           </a:p>
@@ -2018,7 +2018,7 @@
         <p:txBody>
           <a:bodyPr/>
           <a:p>
-            <a:fld id="{1C8AB623-09C9-40CD-9C98-A3304EA471F9}" type="slidenum">
+            <a:fld id="{252D38A1-2414-4044-96EA-D840D8BC847B}" type="slidenum">
               <a:t>&lt;#&gt;</a:t>
             </a:fld>
           </a:p>
@@ -2240,7 +2240,7 @@
         <p:txBody>
           <a:bodyPr/>
           <a:p>
-            <a:fld id="{2F113BD8-164E-4742-93D5-219EA8F5D88F}" type="slidenum">
+            <a:fld id="{A5846650-9CFC-4006-9D43-289C654FFFFF}" type="slidenum">
               <a:t>&lt;#&gt;</a:t>
             </a:fld>
           </a:p>
@@ -2652,7 +2652,7 @@
             <a:pPr algn="r">
               <a:buNone/>
             </a:pPr>
-            <a:fld id="{D399A567-A10B-4081-8D14-C977F1E3BB23}" type="slidenum">
+            <a:fld id="{5301FA0D-A842-45D7-9EA2-F6EFBE4718B8}" type="slidenum">
               <a:rPr b="0" lang="en-US" sz="1400" spc="-1" strike="noStrike">
                 <a:latin typeface="Times New Roman"/>
               </a:rPr>

</xml_diff>

<commit_message>
[MATH-19] Document Lean audit in public PDF guides
</commit_message>
<xml_diff>
--- a/guides/pitches/output/Millennium_Math_Problems_Project_Overview_v1.0.0_EN.pptx
+++ b/guides/pitches/output/Millennium_Math_Problems_Project_Overview_v1.0.0_EN.pptx
@@ -67,7 +67,7 @@
         <p:txBody>
           <a:bodyPr/>
           <a:p>
-            <a:fld id="{4A8C8F92-41CB-40CC-B1E0-1CBF824AB382}" type="slidenum">
+            <a:fld id="{8A4133D6-C34C-4A14-AB53-6F4F388DF0DB}" type="slidenum">
               <a:t>&lt;#&gt;</a:t>
             </a:fld>
           </a:p>
@@ -255,7 +255,7 @@
         <p:txBody>
           <a:bodyPr/>
           <a:p>
-            <a:fld id="{D03CB748-723D-4C8E-88ED-F7DEF9563E52}" type="slidenum">
+            <a:fld id="{8D6CC056-4759-4277-9462-6C6C15B7DE4A}" type="slidenum">
               <a:t>&lt;#&gt;</a:t>
             </a:fld>
           </a:p>
@@ -511,7 +511,7 @@
         <p:txBody>
           <a:bodyPr/>
           <a:p>
-            <a:fld id="{D01DBC8E-1F06-44A9-954A-1CD95A2E361F}" type="slidenum">
+            <a:fld id="{0975131F-1557-4FCE-8C17-BFADBAF8A094}" type="slidenum">
               <a:t>&lt;#&gt;</a:t>
             </a:fld>
           </a:p>
@@ -835,7 +835,7 @@
         <p:txBody>
           <a:bodyPr/>
           <a:p>
-            <a:fld id="{01CBF15C-94BB-4567-BF80-9D946856C8FB}" type="slidenum">
+            <a:fld id="{ED05E568-6FDA-4FC5-86E4-F3ED16BB9E42}" type="slidenum">
               <a:t>&lt;#&gt;</a:t>
             </a:fld>
           </a:p>
@@ -992,7 +992,7 @@
         <p:txBody>
           <a:bodyPr/>
           <a:p>
-            <a:fld id="{AAD5C4EB-C50E-4685-AC71-2B497B8578F2}" type="slidenum">
+            <a:fld id="{0FC3E6A8-444B-46A7-A37F-3EC632DDEE4C}" type="slidenum">
               <a:t>&lt;#&gt;</a:t>
             </a:fld>
           </a:p>
@@ -1146,7 +1146,7 @@
         <p:txBody>
           <a:bodyPr/>
           <a:p>
-            <a:fld id="{18D88305-71FA-4D46-BE70-95E0C1E7C454}" type="slidenum">
+            <a:fld id="{3B482375-5B2A-4F0B-B7B9-CC9D2DD52136}" type="slidenum">
               <a:t>&lt;#&gt;</a:t>
             </a:fld>
           </a:p>
@@ -1334,7 +1334,7 @@
         <p:txBody>
           <a:bodyPr/>
           <a:p>
-            <a:fld id="{095D1C5C-C2BA-40C8-97BC-DFBB08065342}" type="slidenum">
+            <a:fld id="{99600D96-03C0-4CAB-A6AD-CC29907B90FD}" type="slidenum">
               <a:t>&lt;#&gt;</a:t>
             </a:fld>
           </a:p>
@@ -1454,7 +1454,7 @@
         <p:txBody>
           <a:bodyPr/>
           <a:p>
-            <a:fld id="{E0D418C7-D2EB-4D97-ACA6-B28476C44FAA}" type="slidenum">
+            <a:fld id="{519358D2-C90C-4A03-983D-E1BEBC1EB7F1}" type="slidenum">
               <a:t>&lt;#&gt;</a:t>
             </a:fld>
           </a:p>
@@ -1574,7 +1574,7 @@
         <p:txBody>
           <a:bodyPr/>
           <a:p>
-            <a:fld id="{9B64613A-9462-49BF-A53F-D2556F9B8564}" type="slidenum">
+            <a:fld id="{7611A7A0-A7A4-4E5A-8FE3-24A2D0667DA7}" type="slidenum">
               <a:t>&lt;#&gt;</a:t>
             </a:fld>
           </a:p>
@@ -1796,7 +1796,7 @@
         <p:txBody>
           <a:bodyPr/>
           <a:p>
-            <a:fld id="{ABAF194B-EA8A-4AE5-A20D-1D4FF4EE40ED}" type="slidenum">
+            <a:fld id="{F1A696E8-F6E6-4B9A-A6AE-AE63BDDEC679}" type="slidenum">
               <a:t>&lt;#&gt;</a:t>
             </a:fld>
           </a:p>
@@ -2018,7 +2018,7 @@
         <p:txBody>
           <a:bodyPr/>
           <a:p>
-            <a:fld id="{252D38A1-2414-4044-96EA-D840D8BC847B}" type="slidenum">
+            <a:fld id="{34B41999-0C39-4828-A4A4-18457F2A0FAF}" type="slidenum">
               <a:t>&lt;#&gt;</a:t>
             </a:fld>
           </a:p>
@@ -2240,7 +2240,7 @@
         <p:txBody>
           <a:bodyPr/>
           <a:p>
-            <a:fld id="{A5846650-9CFC-4006-9D43-289C654FFFFF}" type="slidenum">
+            <a:fld id="{5D2D55C2-DB53-4C25-BE99-7E5BA96007FB}" type="slidenum">
               <a:t>&lt;#&gt;</a:t>
             </a:fld>
           </a:p>
@@ -2652,7 +2652,7 @@
             <a:pPr algn="r">
               <a:buNone/>
             </a:pPr>
-            <a:fld id="{5301FA0D-A842-45D7-9EA2-F6EFBE4718B8}" type="slidenum">
+            <a:fld id="{8E808B28-0228-4B8E-B132-69BBAC01C1FA}" type="slidenum">
               <a:rPr b="0" lang="en-US" sz="1400" spc="-1" strike="noStrike">
                 <a:latin typeface="Times New Roman"/>
               </a:rPr>

</xml_diff>